<commit_message>
Drop the contrastive sentence pattern; render the same deck to the web
Rewrites all 15 places that used the "not X but Y" construction into
direct positive statements. Titles already carried no punctuation; a check
in the build confirms both.

Adds 06_build_web_deck.py, which renders slides_content.py to the online
deck's HTML instead of PowerPoint. Both renderers read the same content
module, so the two decks cannot drift apart - editing the copy in one
place updates both.

Co-Authored-By: Claude Opus 5 <noreply@anthropic.com>
</commit_message>
<xml_diff>
--- a/變換車道的外部成本.pptx
+++ b/變換車道的外部成本.pptx
@@ -4833,7 +4833,7 @@
                 <a:ea typeface="Microsoft JhengHei"/>
                 <a:cs typeface="Microsoft JhengHei"/>
               </a:rPr>
-              <a:t>排除的 Lankershim 與 Peachtree 是設有號誌的市區幹道。在那裡後車減速通常是因為紅燈，不是因為前方有車切入。</a:t>
+              <a:t>排除的 Lankershim 與 Peachtree 是設有號誌的市區幹道。在那裡後車減速多半源自紅燈，與前方車輛切入無關。</a:t>
             </a:r>
           </a:p>
           <a:p>
@@ -10263,7 +10263,7 @@
                 <a:ea typeface="Microsoft JhengHei"/>
                 <a:cs typeface="Microsoft JhengHei"/>
               </a:rPr>
-              <a:t>報告的外部成本是</a:t>
+              <a:t>報告的外部成本一律取</a:t>
             </a:r>
             <a:r>
               <a:rPr sz="1500" b="1">
@@ -10285,7 +10285,7 @@
                 <a:ea typeface="Microsoft JhengHei"/>
                 <a:cs typeface="Microsoft JhengHei"/>
               </a:rPr>
-              <a:t>，不是事件組的原始掉幅。</a:t>
+              <a:t>。事件組的原始掉幅只是中間產物。</a:t>
             </a:r>
           </a:p>
         </p:txBody>
@@ -11839,7 +11839,7 @@
                 <a:ea typeface="Microsoft JhengHei"/>
                 <a:cs typeface="Microsoft JhengHei"/>
               </a:rPr>
-              <a:t>不以宣稱代替檢查。以下用的是估計式從未看過的欄位，因此是獨立驗證而非循環論證。</a:t>
+              <a:t>配對品質需要檢查。以下用的是估計式從未看過的欄位，屬於獨立驗證。</a:t>
             </a:r>
           </a:p>
         </p:txBody>
@@ -12454,7 +12454,7 @@
                 <a:ea typeface="Microsoft JhengHei"/>
                 <a:cs typeface="Microsoft JhengHei"/>
               </a:rPr>
-              <a:t>兩種方法互相檢查，而不是只用其中一種。</a:t>
+              <a:t>兩種方法互相檢查。</a:t>
             </a:r>
           </a:p>
         </p:txBody>
@@ -12668,7 +12668,7 @@
                 <a:ea typeface="Microsoft JhengHei"/>
                 <a:cs typeface="Microsoft JhengHei"/>
               </a:rPr>
-              <a:t>每一個差異都報 95% 信賴區間而非點估計。固定亂數種子，結果完全可重現</a:t>
+              <a:t>每一個差異都報 95% 信賴區間。固定亂數種子，結果完全可重現</a:t>
             </a:r>
           </a:p>
         </p:txBody>
@@ -13736,7 +13736,7 @@
                 <a:ea typeface="Microsoft JhengHei"/>
                 <a:cs typeface="Microsoft JhengHei"/>
               </a:rPr>
-              <a:t>貨車事件僅 54 筆，對比小客車 2,418 筆。因此全部報信賴區間而非點估計。這個結果值得注意，是因為它推翻了專案原本的假設，不是因為它精確。</a:t>
+              <a:t>貨車事件僅 54 筆，對比小客車 2,418 筆，因此全部報信賴區間。這個結果的價值在於它推翻了專案原本的假設，精確度本身有限。</a:t>
             </a:r>
           </a:p>
         </p:txBody>
@@ -15506,7 +15506,7 @@
                 <a:ea typeface="Microsoft JhengHei"/>
                 <a:cs typeface="Microsoft JhengHei"/>
               </a:rPr>
-              <a:t>擾動是</a:t>
+              <a:t>擾動</a:t>
             </a:r>
             <a:r>
               <a:rPr sz="1100" b="1">
@@ -15528,7 +15528,7 @@
                 <a:ea typeface="Microsoft JhengHei"/>
                 <a:cs typeface="Microsoft JhengHei"/>
               </a:rPr>
-              <a:t>的，不是持續的損失。本分析</a:t>
+              <a:t>，持續時間極短。本分析</a:t>
             </a:r>
             <a:r>
               <a:rPr sz="1100" b="1">
@@ -17606,7 +17606,7 @@
                 <a:ea typeface="Microsoft JhengHei"/>
                 <a:cs typeface="Microsoft JhengHei"/>
               </a:rPr>
-              <a:t>不是固定罰分</a:t>
+              <a:t>依實測路況加權</a:t>
             </a:r>
           </a:p>
           <a:p>
@@ -17713,7 +17713,7 @@
                 <a:ea typeface="Microsoft JhengHei"/>
                 <a:cs typeface="Microsoft JhengHei"/>
               </a:rPr>
-              <a:t>不是抽象理想值</a:t>
+              <a:t>以觀測到的行為為準</a:t>
             </a:r>
           </a:p>
           <a:p>
@@ -17844,7 +17844,7 @@
                 <a:ea typeface="Microsoft JhengHei"/>
                 <a:cs typeface="Microsoft JhengHei"/>
               </a:rPr>
-              <a:t>輔導改變行為，改變被重新量測，模型被重新估計。服務在學習什麼有效，而非宣稱</a:t>
+              <a:t>輔導改變行為，改變被重新量測，模型被重新估計。服務持續學習什麼真正有效</a:t>
             </a:r>
           </a:p>
         </p:txBody>
@@ -18613,7 +18613,7 @@
                 <a:ea typeface="Microsoft JhengHei"/>
                 <a:cs typeface="Microsoft JhengHei"/>
               </a:rPr>
-              <a:t>差異不在演算法，而在</a:t>
+              <a:t>差異的核心是</a:t>
             </a:r>
             <a:r>
               <a:rPr sz="1100" b="1">
@@ -18810,7 +18810,7 @@
                 <a:ea typeface="Microsoft JhengHei"/>
                 <a:cs typeface="Microsoft JhengHei"/>
               </a:rPr>
-              <a:t>。配對、分層與穩健迴歸回答「有多大，以及是不是真的」。這部分必須維持可解釋，因為會影響駕駛薪酬的評分必須能對駕駛解釋。</a:t>
+              <a:t>。配對、分層與穩健迴歸回答「有多大，以及是否為真」。這部分必須維持可解釋，因為會影響駕駛薪酬的評分必須能對駕駛解釋。</a:t>
             </a:r>
           </a:p>
           <a:p>
@@ -20105,7 +20105,7 @@
                 <a:ea typeface="Microsoft JhengHei"/>
                 <a:cs typeface="Microsoft JhengHei"/>
               </a:rPr>
-              <a:t>，不是結論來源。</a:t>
+              <a:t>，結論仍須由本地資料產生。</a:t>
             </a:r>
           </a:p>
         </p:txBody>
@@ -24121,7 +24121,7 @@
                 <a:ea typeface="Microsoft JhengHei"/>
                 <a:cs typeface="Microsoft JhengHei"/>
               </a:rPr>
-              <a:t>這份分析的對象是</a:t>
+              <a:t>這份分析直接以</a:t>
             </a:r>
             <a:r>
               <a:rPr sz="1600" b="1">
@@ -24143,7 +24143,7 @@
                 <a:ea typeface="Microsoft JhengHei"/>
                 <a:cs typeface="Microsoft JhengHei"/>
               </a:rPr>
-              <a:t>，不是抽象的車流。</a:t>
+              <a:t>為對象。</a:t>
             </a:r>
           </a:p>
           <a:p>
@@ -24167,7 +24167,7 @@
                 <a:ea typeface="Microsoft JhengHei"/>
                 <a:cs typeface="Microsoft JhengHei"/>
               </a:rPr>
-              <a:t>NGSIM 的車種欄位可以把貨車單獨拆出來分析，因此物流的相關性是</a:t>
+              <a:t>NGSIM 的車種欄位可以把貨車單獨拆出來分析，物流的相關性因此寫在</a:t>
             </a:r>
             <a:r>
               <a:rPr sz="1500" b="1">
@@ -24178,7 +24178,7 @@
                 <a:ea typeface="Microsoft JhengHei"/>
                 <a:cs typeface="Microsoft JhengHei"/>
               </a:rPr>
-              <a:t>結構性的</a:t>
+              <a:t>資料結構</a:t>
             </a:r>
             <a:r>
               <a:rPr sz="1500" b="0">
@@ -24189,7 +24189,7 @@
                 <a:ea typeface="Microsoft JhengHei"/>
                 <a:cs typeface="Microsoft JhengHei"/>
               </a:rPr>
-              <a:t>，不是事後附加的說詞。</a:t>
+              <a:t>裡，有欄位可以驗證。</a:t>
             </a:r>
           </a:p>
           <a:p>

</xml_diff>